<commit_message>
Align with brand manual, merge Effective Size, support Claude and Codex
</commit_message>
<xml_diff>
--- a/assets/NT_Presentation_Template.pptx
+++ b/assets/NT_Presentation_Template.pptx
@@ -563,7 +563,7 @@
               <a:buNone/>
               <a:defRPr sz="5400">
                 <a:solidFill>
-                  <a:srgbClr val="54595F"/>
+                  <a:srgbClr val="545859"/>
                 </a:solidFill>
                 <a:latin typeface="NT Bold"/>
                 <a:ea typeface="NT Bold"/>
@@ -575,7 +575,7 @@
               <a:buFontTx/>
               <a:defRPr sz="5400">
                 <a:solidFill>
-                  <a:srgbClr val="54595F"/>
+                  <a:srgbClr val="545859"/>
                 </a:solidFill>
                 <a:latin typeface="NT Bold"/>
                 <a:ea typeface="NT Bold"/>
@@ -587,7 +587,7 @@
               <a:buFontTx/>
               <a:defRPr sz="5400">
                 <a:solidFill>
-                  <a:srgbClr val="54595F"/>
+                  <a:srgbClr val="545859"/>
                 </a:solidFill>
                 <a:latin typeface="NT Bold"/>
                 <a:ea typeface="NT Bold"/>
@@ -599,7 +599,7 @@
               <a:buFontTx/>
               <a:defRPr sz="5400">
                 <a:solidFill>
-                  <a:srgbClr val="54595F"/>
+                  <a:srgbClr val="545859"/>
                 </a:solidFill>
                 <a:latin typeface="NT Bold"/>
                 <a:ea typeface="NT Bold"/>
@@ -611,7 +611,7 @@
               <a:buFontTx/>
               <a:defRPr sz="5400">
                 <a:solidFill>
-                  <a:srgbClr val="54595F"/>
+                  <a:srgbClr val="545859"/>
                 </a:solidFill>
                 <a:latin typeface="NT Bold"/>
                 <a:ea typeface="NT Bold"/>

</xml_diff>